<commit_message>
Kahramankazan Uydukent: gösterim sürümü (sunum ve rapor PDF)
- Sunum: 7. slayt Sarıayak bölgesi; slayt altlığında ve kapakta "Taslak" yok
- Sunumun PDF çıktısı eklendi
- Rapor: Kahramankazan Uydukent fizibilitesi (md ve 46 sayfalık PDF);
  build_v2.py yeni rapora ve altlığa göre güncellendi

Co-Authored-By: Claude Opus 5.5 <noreply@anthropic.com>
Claude-Session: https://claude.ai/code/session_017Bigq3wz42fLbgMKrFhXXw
</commit_message>
<xml_diff>
--- a/reports/Kahramankazan Uydukent sunumu.pptx
+++ b/reports/Kahramankazan Uydukent sunumu.pptx
@@ -131,7 +131,7 @@
   <p:extLst>
     <p:ext uri="{521415D9-36F7-43E2-AB2F-B90AF26B5E84}">
       <p14:sectionLst xmlns:p14="http://schemas.microsoft.com/office/powerpoint/2010/main">
-        <p14:section name="Giriş" id="{d1d22c8b-eced-20c9-9f18-3ddce37fd8f3}">
+        <p14:section name="Giriş" id="{1233ba2c-aeab-8567-cfd3-f963ef9b5157}">
           <p14:sldIdLst>
             <p14:sldId id="256"/>
             <p14:sldId id="257"/>
@@ -139,7 +139,7 @@
             <p14:sldId id="259"/>
           </p14:sldIdLst>
         </p14:section>
-        <p14:section name="Yer ve saha" id="{a1c532cb-38fa-bd27-ce52-242673e020ea}">
+        <p14:section name="Yer ve saha" id="{a0faedc3-cc9f-5219-6d20-c23ed9f99aef}">
           <p14:sldIdLst>
             <p14:sldId id="260"/>
             <p14:sldId id="261"/>
@@ -148,7 +148,7 @@
             <p14:sldId id="264"/>
           </p14:sldIdLst>
         </p14:section>
-        <p14:section name="Yaşam alanı" id="{03e5e357-67d1-7f58-fc0f-5b0d0c5f8b15}">
+        <p14:section name="Yaşam alanı" id="{00e79fc4-1e73-84c4-3fe3-dcedd4b93410}">
           <p14:sldIdLst>
             <p14:sldId id="265"/>
             <p14:sldId id="266"/>
@@ -162,13 +162,13 @@
             <p14:sldId id="274"/>
           </p14:sldIdLst>
         </p14:section>
-        <p14:section name="Yatırım ve fayda" id="{3ce0b129-ce19-0842-a1e8-343d87001cfb}">
+        <p14:section name="Yatırım ve fayda" id="{5b80f16e-bcca-6855-46d2-70a5589e59d9}">
           <p14:sldIdLst>
             <p14:sldId id="275"/>
             <p14:sldId id="276"/>
           </p14:sldIdLst>
         </p14:section>
-        <p14:section name="Uygulama" id="{6ecd0f57-1289-6c71-b7ee-e894cb3ea834}">
+        <p14:section name="Uygulama" id="{561691b3-f86c-416c-3ef3-4555ce56f0d2}">
           <p14:sldIdLst>
             <p14:sldId id="277"/>
             <p14:sldId id="278"/>
@@ -2141,7 +2141,7 @@
           <a:p>
             <a:r>
               <a:rPr lang="en-US" dirty="0"/>
-              <a:t>Açılış. Belen &amp; Partners olarak Kahramankazan Sarıayak'taki 511 bin metrekarelik Hazine arazisi için hazırladığımız Kahramankazan Uydukent fizibilitesini sunuyoruz. Arka plandaki fotoğraf bölgeden Kahramankazan ovasına bakıyor; drone çekimi 22 Eylül 2026. Bu bir taslaktır; rakamların bir kısmı kurumlardan teyit bekliyor.</a:t>
+              <a:t>Açılış. Belen &amp; Partners olarak Kahramankazan Sarıayak'taki 511 bin metrekarelik Hazine arazisi için hazırladığımız Kahramankazan Uydukent fizibilitesini sunuyoruz. Arka plandaki fotoğraf bölgeden Kahramankazan ovasına bakıyor; drone çekimi 22 Eylül 2026. Rakamların bir kısmı kurumlardan teyit bekliyor.</a:t>
             </a:r>
             <a:endParaRPr lang="en-US" dirty="0"/>
           </a:p>
@@ -4077,7 +4077,7 @@
           <a:p>
             <a:r>
               <a:rPr lang="en-US" dirty="0"/>
-              <a:t>Drone görüntüleri bölgenin arazi tipini gösteriyor; çekim Örencik çevresinde yapıldı, Sarıayak parselinin topoğrafyası ayrıca teyit edilecek. Arazi düz değil. Tepe üstündeki buğday platoları yapılaşmaya uygun bölümler. Yamaçlarda erozyon yarıntıları ve eşyükselti teraslarına dikilmiş genç çamlar var; bu teraslı ağaçlandırmanın hukuki statüsü teyit edilecek. Vadilerde eski köy yerleşimleri var; yeni yaşam alanı mevcut köyle birlikte tasarlanmalı. Platolardan ovaya geniş bir manzara açılıyor; bu bir değer.</a:t>
+              <a:t>Drone görüntüleri Sarıayak bölgesinin arazi tipini gösteriyor; parsel sınırı işaretli değil, topoğrafya halihazır haritayla teyit edilecek. Arazi düz değil. Tepe üstündeki buğday platoları yapılaşmaya uygun bölümler. Yamaçlarda erozyon yarıntıları ve eşyükselti teraslarına dikilmiş genç çamlar var; bu teraslı ağaçlandırmanın hukuki statüsü teyit edilecek. Vadilerde eski köy yerleşimleri var; yeni yaşam alanı mevcut köyle birlikte tasarlanmalı. Platolardan ovaya geniş bir manzara açılıyor; bu bir değer.</a:t>
             </a:r>
             <a:endParaRPr lang="en-US" dirty="0"/>
           </a:p>
@@ -4457,7 +4457,7 @@
                   <a:schemeClr val="accent5"/>
                 </a:solidFill>
               </a:rPr>
-              <a:t>Belen &amp; Partners · Kahramankazan Uydukent fizibilitesi · Ekim 2026 · Taslak</a:t>
+              <a:t>Belen &amp; Partners · Kahramankazan Uydukent fizibilitesi · Ekim 2026</a:t>
             </a:r>
             <a:endParaRPr lang="en-US" sz="1000" dirty="0"/>
           </a:p>
@@ -4648,7 +4648,7 @@
                   <a:schemeClr val="bg2"/>
                 </a:solidFill>
               </a:rPr>
-              <a:t>Belen &amp; Partners · Kahramankazan Uydukent fizibilitesi · Ekim 2026 · Taslak</a:t>
+              <a:t>Belen &amp; Partners · Kahramankazan Uydukent fizibilitesi · Ekim 2026</a:t>
             </a:r>
             <a:endParaRPr lang="en-US" sz="1000" dirty="0"/>
           </a:p>
@@ -4949,7 +4949,7 @@
                   <a:schemeClr val="bg2"/>
                 </a:solidFill>
               </a:rPr>
-              <a:t>Belen &amp; Partners · Kahramankazan Uydukent fizibilitesi · Ekim 2026 · Taslak</a:t>
+              <a:t>Belen &amp; Partners · Kahramankazan Uydukent fizibilitesi · Ekim 2026</a:t>
             </a:r>
             <a:endParaRPr lang="en-US" sz="1000" dirty="0"/>
           </a:p>
@@ -5382,7 +5382,7 @@
                   <a:schemeClr val="accent4"/>
                 </a:solidFill>
               </a:rPr>
-              <a:t>FİZİBİLİTE SUNUMU · TASLAK</a:t>
+              <a:t>FİZİBİLİTE SUNUMU</a:t>
             </a:r>
             <a:endParaRPr lang="en-US" sz="1400" dirty="0"/>
           </a:p>
@@ -30378,7 +30378,7 @@
       </p:sp>
       <p:pic>
         <p:nvPicPr>
-          <p:cNvPr id="4" name="Örencik köyü ve plato" descr="/home/user/sunum/araclar/sunum/assets/saha_buyuk.jpg">    </p:cNvPr>
+          <p:cNvPr id="4" name="Sarıayak bölgesinde köy ve plato" descr="/home/user/sunum/araclar/sunum/assets/saha_buyuk.jpg">    </p:cNvPr>
           <p:cNvPicPr>
             <a:picLocks noChangeAspect="1"/>
           </p:cNvPicPr>
@@ -30457,7 +30457,7 @@
         <p:spPr>
           <a:xfrm>
             <a:off x="731520" y="5440680"/>
-            <a:ext cx="3840480" cy="365760"/>
+            <a:ext cx="3383280" cy="365760"/>
           </a:xfrm>
           <a:prstGeom prst="roundRect">
             <a:avLst>
@@ -30484,7 +30484,7 @@
                   <a:schemeClr val="bg1"/>
                 </a:solidFill>
               </a:rPr>
-              <a:t>Vadide eski Örencik köyü, platoda tarlalar</a:t>
+              <a:t>Vadide köy yerleşimi, platoda tarlalar</a:t>
             </a:r>
             <a:endParaRPr lang="en-US" sz="1300" dirty="0"/>
           </a:p>
@@ -30604,7 +30604,7 @@
                   <a:schemeClr val="accent5"/>
                 </a:solidFill>
               </a:rPr>
-              <a:t>Drone çekimi: 22 Eylül 2026, Örencik çevresi, proje ekibi. Görüntüler bölgenin arazi tipini gösterir; Sarıayak parseli ayrıca teyit edilecek.</a:t>
+              <a:t>Drone çekimi: 22 Eylül 2026, Sarıayak bölgesi, proje ekibi. Parsel sınırı işaretli değildir; topoğrafya halihazır haritayla teyit edilecek.</a:t>
             </a:r>
             <a:endParaRPr lang="en-US" sz="1100" dirty="0"/>
           </a:p>

</xml_diff>